<commit_message>
Update Formato Presentación final.pptx
se inicio el rellenado de información requerida de PPT para la defensa
</commit_message>
<xml_diff>
--- a/Fase 3/Evidencias Grupales/Formato Presentación final.pptx
+++ b/Fase 3/Evidencias Grupales/Formato Presentación final.pptx
@@ -117,6 +117,11 @@
       </a:defRPr>
     </a:lvl9pPr>
   </p:defaultTextStyle>
+  <p:extLst>
+    <p:ext uri="{EFAFB233-063F-42B5-8137-9DF3F51BA10A}">
+      <p15:sldGuideLst xmlns:p15="http://schemas.microsoft.com/office/powerpoint/2012/main"/>
+    </p:ext>
+  </p:extLst>
 </p:presentation>
 </file>
 
@@ -890,7 +895,7 @@
         <a:p>
           <a:r>
             <a:rPr lang="es-MX" dirty="0"/>
-            <a:t>Nombre de estudiante</a:t>
+            <a:t>Benjamín Alejandro Bravo Rivadeneira</a:t>
           </a:r>
           <a:endParaRPr lang="es-CL" dirty="0"/>
         </a:p>
@@ -908,43 +913,6 @@
       </dgm:t>
     </dgm:pt>
     <dgm:pt modelId="{E88D0928-51D4-4670-8963-60ABBB193E13}" type="sibTrans" cxnId="{2AD07198-D472-4B98-B6D5-5A730374E9A2}">
-      <dgm:prSet/>
-      <dgm:spPr/>
-      <dgm:t>
-        <a:bodyPr/>
-        <a:lstStyle/>
-        <a:p>
-          <a:endParaRPr lang="es-CL"/>
-        </a:p>
-      </dgm:t>
-    </dgm:pt>
-    <dgm:pt modelId="{D868444B-AE34-4422-A6A5-1F7D392D0C20}">
-      <dgm:prSet phldrT="[Texto]"/>
-      <dgm:spPr/>
-      <dgm:t>
-        <a:bodyPr/>
-        <a:lstStyle/>
-        <a:p>
-          <a:r>
-            <a:rPr lang="es-MX" dirty="0"/>
-            <a:t>Cargo</a:t>
-          </a:r>
-          <a:endParaRPr lang="es-CL" dirty="0"/>
-        </a:p>
-      </dgm:t>
-    </dgm:pt>
-    <dgm:pt modelId="{7DB88D83-6C3A-48C1-8CAD-0D11C3BEC35C}" type="parTrans" cxnId="{484B8A37-0122-4FF5-93D2-4A15DF521A17}">
-      <dgm:prSet/>
-      <dgm:spPr/>
-      <dgm:t>
-        <a:bodyPr/>
-        <a:lstStyle/>
-        <a:p>
-          <a:endParaRPr lang="es-CL"/>
-        </a:p>
-      </dgm:t>
-    </dgm:pt>
-    <dgm:pt modelId="{74B9B1A5-94EB-40A9-BFF2-678501068FB8}" type="sibTrans" cxnId="{484B8A37-0122-4FF5-93D2-4A15DF521A17}">
       <dgm:prSet/>
       <dgm:spPr/>
       <dgm:t>
@@ -1019,43 +987,6 @@
       </dgm:t>
     </dgm:pt>
     <dgm:pt modelId="{1CCC8D2D-CD28-4814-B055-28ABD65CA276}" type="sibTrans" cxnId="{4FE7AF63-70AC-4ED4-8BFB-DCB2408F3318}">
-      <dgm:prSet/>
-      <dgm:spPr/>
-      <dgm:t>
-        <a:bodyPr/>
-        <a:lstStyle/>
-        <a:p>
-          <a:endParaRPr lang="es-CL"/>
-        </a:p>
-      </dgm:t>
-    </dgm:pt>
-    <dgm:pt modelId="{2E221207-005F-49CB-81E1-6D036D64322B}">
-      <dgm:prSet phldrT="[Texto]"/>
-      <dgm:spPr/>
-      <dgm:t>
-        <a:bodyPr/>
-        <a:lstStyle/>
-        <a:p>
-          <a:r>
-            <a:rPr lang="es-MX" dirty="0"/>
-            <a:t>Funciones desempeñadas</a:t>
-          </a:r>
-          <a:endParaRPr lang="es-CL" dirty="0"/>
-        </a:p>
-      </dgm:t>
-    </dgm:pt>
-    <dgm:pt modelId="{3728DB5E-E904-481D-A1E5-49CF4AFFC0D3}" type="sibTrans" cxnId="{1C3272C9-C630-4D60-B76B-138907BB4D41}">
-      <dgm:prSet/>
-      <dgm:spPr/>
-      <dgm:t>
-        <a:bodyPr/>
-        <a:lstStyle/>
-        <a:p>
-          <a:endParaRPr lang="es-CL"/>
-        </a:p>
-      </dgm:t>
-    </dgm:pt>
-    <dgm:pt modelId="{B200B6AA-AA2A-4CB8-80FF-4BB54938E8A5}" type="parTrans" cxnId="{1C3272C9-C630-4D60-B76B-138907BB4D41}">
       <dgm:prSet/>
       <dgm:spPr/>
       <dgm:t>
@@ -1214,6 +1145,66 @@
         </a:p>
       </dgm:t>
     </dgm:pt>
+    <dgm:pt modelId="{D868444B-AE34-4422-A6A5-1F7D392D0C20}">
+      <dgm:prSet phldrT="[Texto]"/>
+      <dgm:spPr/>
+      <dgm:t>
+        <a:bodyPr/>
+        <a:lstStyle/>
+        <a:p>
+          <a:r>
+            <a:rPr lang="es-MX" dirty="0"/>
+            <a:t>Gestor de proyectos y Líder del proyecto</a:t>
+          </a:r>
+          <a:endParaRPr lang="es-CL" dirty="0"/>
+        </a:p>
+      </dgm:t>
+    </dgm:pt>
+    <dgm:pt modelId="{74B9B1A5-94EB-40A9-BFF2-678501068FB8}" type="sibTrans" cxnId="{484B8A37-0122-4FF5-93D2-4A15DF521A17}">
+      <dgm:prSet/>
+      <dgm:spPr/>
+      <dgm:t>
+        <a:bodyPr/>
+        <a:lstStyle/>
+        <a:p>
+          <a:endParaRPr lang="es-CL"/>
+        </a:p>
+      </dgm:t>
+    </dgm:pt>
+    <dgm:pt modelId="{7DB88D83-6C3A-48C1-8CAD-0D11C3BEC35C}" type="parTrans" cxnId="{484B8A37-0122-4FF5-93D2-4A15DF521A17}">
+      <dgm:prSet/>
+      <dgm:spPr/>
+      <dgm:t>
+        <a:bodyPr/>
+        <a:lstStyle/>
+        <a:p>
+          <a:endParaRPr lang="es-CL"/>
+        </a:p>
+      </dgm:t>
+    </dgm:pt>
+    <dgm:pt modelId="{62F1AA66-C25A-4E90-9F94-A2481F187857}">
+      <dgm:prSet phldrT="[Texto]"/>
+      <dgm:spPr/>
+      <dgm:t>
+        <a:bodyPr/>
+        <a:lstStyle/>
+        <a:p>
+          <a:r>
+            <a:rPr lang="es-MX" dirty="0"/>
+            <a:t>Tener los documentos, ayudar y guiar al equipo</a:t>
+          </a:r>
+          <a:endParaRPr lang="es-CL" dirty="0"/>
+        </a:p>
+      </dgm:t>
+    </dgm:pt>
+    <dgm:pt modelId="{7F4727AC-1BDA-4A7C-9217-23F0312BC14B}" type="parTrans" cxnId="{24A7E5C3-B54B-4DF2-8B73-0A88F3EB4070}">
+      <dgm:prSet/>
+      <dgm:spPr/>
+    </dgm:pt>
+    <dgm:pt modelId="{C526E7B5-A8A2-4E42-843E-203585FE8244}" type="sibTrans" cxnId="{24A7E5C3-B54B-4DF2-8B73-0A88F3EB4070}">
+      <dgm:prSet/>
+      <dgm:spPr/>
+    </dgm:pt>
     <dgm:pt modelId="{6E1E561E-88C1-49C6-A3F7-DE4B9AD43273}" type="pres">
       <dgm:prSet presAssocID="{BE45140C-C326-4DAA-A267-498AD5117D68}" presName="linear" presStyleCnt="0">
         <dgm:presLayoutVars>
@@ -1233,7 +1224,21 @@
     </dgm:pt>
     <dgm:pt modelId="{9A7E2690-DE9C-4572-9BE5-B8C9A3B8BBB3}" type="pres">
       <dgm:prSet presAssocID="{78BFB295-8F5D-4286-B72B-79142F8F0E13}" presName="img" presStyleLbl="fgImgPlace1" presStyleIdx="0" presStyleCnt="3"/>
-      <dgm:spPr/>
+      <dgm:spPr>
+        <a:blipFill>
+          <a:blip xmlns:r="http://schemas.openxmlformats.org/officeDocument/2006/relationships" r:embed="rId1">
+            <a:extLst>
+              <a:ext uri="{28A0092B-C50C-407E-A947-70E740481C1C}">
+                <a14:useLocalDpi xmlns:a14="http://schemas.microsoft.com/office/drawing/2010/main" val="0"/>
+              </a:ext>
+            </a:extLst>
+          </a:blip>
+          <a:srcRect/>
+          <a:stretch>
+            <a:fillRect t="-66000" b="-66000"/>
+          </a:stretch>
+        </a:blipFill>
+      </dgm:spPr>
     </dgm:pt>
     <dgm:pt modelId="{52D125D2-FCA7-4A2D-AB39-B6BD54F251F2}" type="pres">
       <dgm:prSet presAssocID="{78BFB295-8F5D-4286-B72B-79142F8F0E13}" presName="text" presStyleLbl="node1" presStyleIdx="0" presStyleCnt="3">
@@ -1293,7 +1298,6 @@
     </dgm:pt>
   </dgm:ptLst>
   <dgm:cxnLst>
-    <dgm:cxn modelId="{399BD705-2380-48A3-9C48-1D49A5A32D61}" type="presOf" srcId="{2E221207-005F-49CB-81E1-6D036D64322B}" destId="{52D125D2-FCA7-4A2D-AB39-B6BD54F251F2}" srcOrd="1" destOrd="2" presId="urn:microsoft.com/office/officeart/2005/8/layout/vList4"/>
     <dgm:cxn modelId="{D2B94F0C-C779-4AC1-87E4-35116A3DED02}" type="presOf" srcId="{78BFB295-8F5D-4286-B72B-79142F8F0E13}" destId="{54FC4CB6-0791-48D3-B2C5-2E99B8AFCFF7}" srcOrd="0" destOrd="0" presId="urn:microsoft.com/office/officeart/2005/8/layout/vList4"/>
     <dgm:cxn modelId="{D5771F2D-99A4-4884-A896-FA1E2DEFDD88}" srcId="{99FF0D0F-282A-4030-9AF5-3B7621881539}" destId="{A2BD12B5-7AB5-4859-B57E-1E77C0ED35DF}" srcOrd="0" destOrd="0" parTransId="{AC7F7F07-A811-4CCD-BBFE-DAA4D1F5EE40}" sibTransId="{35EEEEB1-B116-40C6-8142-8F938AF38B0B}"/>
     <dgm:cxn modelId="{3A21ED2D-BFFE-4942-BD04-AB5B9DC419E5}" type="presOf" srcId="{99FF0D0F-282A-4030-9AF5-3B7621881539}" destId="{F36F4ED1-B414-46B8-A8C5-C0FB11F5CFBC}" srcOrd="0" destOrd="0" presId="urn:microsoft.com/office/officeart/2005/8/layout/vList4"/>
@@ -1309,16 +1313,17 @@
     <dgm:cxn modelId="{2AD07198-D472-4B98-B6D5-5A730374E9A2}" srcId="{BE45140C-C326-4DAA-A267-498AD5117D68}" destId="{78BFB295-8F5D-4286-B72B-79142F8F0E13}" srcOrd="0" destOrd="0" parTransId="{F1885FAB-61EC-4F80-98D0-72360031AF9F}" sibTransId="{E88D0928-51D4-4670-8963-60ABBB193E13}"/>
     <dgm:cxn modelId="{FBEF4C9A-E5D4-462C-B35F-96C87426BEAB}" type="presOf" srcId="{A2BD12B5-7AB5-4859-B57E-1E77C0ED35DF}" destId="{F36F4ED1-B414-46B8-A8C5-C0FB11F5CFBC}" srcOrd="0" destOrd="1" presId="urn:microsoft.com/office/officeart/2005/8/layout/vList4"/>
     <dgm:cxn modelId="{690A389C-25C1-485B-88F9-437236A47744}" type="presOf" srcId="{BE45140C-C326-4DAA-A267-498AD5117D68}" destId="{6E1E561E-88C1-49C6-A3F7-DE4B9AD43273}" srcOrd="0" destOrd="0" presId="urn:microsoft.com/office/officeart/2005/8/layout/vList4"/>
+    <dgm:cxn modelId="{6371ED9D-4AE7-44F3-8BCE-C936BF4BA99F}" type="presOf" srcId="{62F1AA66-C25A-4E90-9F94-A2481F187857}" destId="{54FC4CB6-0791-48D3-B2C5-2E99B8AFCFF7}" srcOrd="0" destOrd="2" presId="urn:microsoft.com/office/officeart/2005/8/layout/vList4"/>
     <dgm:cxn modelId="{ECFD91A4-F44F-4C84-8B25-37DA0B249A1F}" type="presOf" srcId="{78BFB295-8F5D-4286-B72B-79142F8F0E13}" destId="{52D125D2-FCA7-4A2D-AB39-B6BD54F251F2}" srcOrd="1" destOrd="0" presId="urn:microsoft.com/office/officeart/2005/8/layout/vList4"/>
     <dgm:cxn modelId="{67DE09B5-392E-4661-A7AE-A0572D63DA68}" type="presOf" srcId="{99FF0D0F-282A-4030-9AF5-3B7621881539}" destId="{0E12AD21-08CC-4736-A269-DD5234F9D874}" srcOrd="1" destOrd="0" presId="urn:microsoft.com/office/officeart/2005/8/layout/vList4"/>
     <dgm:cxn modelId="{778F2DBC-81F3-476D-BD99-784E4F7153C8}" srcId="{02A34BC0-F8BA-4A89-87A4-4F20079DFD06}" destId="{EA3B2395-55AF-495E-9D6B-329D2886612F}" srcOrd="0" destOrd="0" parTransId="{01DA10B6-3F7A-4C8A-AACD-F605EE6CCF20}" sibTransId="{11A4E056-7834-4F82-8A9C-B8EA31F159E3}"/>
+    <dgm:cxn modelId="{771AC4C3-43B6-4708-AF74-1C09D131840F}" type="presOf" srcId="{62F1AA66-C25A-4E90-9F94-A2481F187857}" destId="{52D125D2-FCA7-4A2D-AB39-B6BD54F251F2}" srcOrd="1" destOrd="2" presId="urn:microsoft.com/office/officeart/2005/8/layout/vList4"/>
+    <dgm:cxn modelId="{24A7E5C3-B54B-4DF2-8B73-0A88F3EB4070}" srcId="{78BFB295-8F5D-4286-B72B-79142F8F0E13}" destId="{62F1AA66-C25A-4E90-9F94-A2481F187857}" srcOrd="1" destOrd="0" parTransId="{7F4727AC-1BDA-4A7C-9217-23F0312BC14B}" sibTransId="{C526E7B5-A8A2-4E42-843E-203585FE8244}"/>
     <dgm:cxn modelId="{FE5360C5-555C-42B2-9E63-16D2D46F21B1}" type="presOf" srcId="{D868444B-AE34-4422-A6A5-1F7D392D0C20}" destId="{52D125D2-FCA7-4A2D-AB39-B6BD54F251F2}" srcOrd="1" destOrd="1" presId="urn:microsoft.com/office/officeart/2005/8/layout/vList4"/>
-    <dgm:cxn modelId="{1C3272C9-C630-4D60-B76B-138907BB4D41}" srcId="{78BFB295-8F5D-4286-B72B-79142F8F0E13}" destId="{2E221207-005F-49CB-81E1-6D036D64322B}" srcOrd="1" destOrd="0" parTransId="{B200B6AA-AA2A-4CB8-80FF-4BB54938E8A5}" sibTransId="{3728DB5E-E904-481D-A1E5-49CF4AFFC0D3}"/>
     <dgm:cxn modelId="{B0C181C9-77EB-4775-B9E6-C6CBDA60E6EB}" type="presOf" srcId="{EA3B2395-55AF-495E-9D6B-329D2886612F}" destId="{CFFDF23F-D296-4CDF-8EE4-8A672559E207}" srcOrd="1" destOrd="1" presId="urn:microsoft.com/office/officeart/2005/8/layout/vList4"/>
     <dgm:cxn modelId="{ECED70CB-7A25-48F8-9E03-51596FB1E92C}" srcId="{02A34BC0-F8BA-4A89-87A4-4F20079DFD06}" destId="{55A2A9EB-4C26-43C3-B721-D475B10BC39B}" srcOrd="1" destOrd="0" parTransId="{B8424EB2-FFE7-4867-9D5A-EE0D46E8AAFE}" sibTransId="{4EF4588A-187C-4393-9DFC-C6D80B20E995}"/>
     <dgm:cxn modelId="{D1C04ECF-982A-425F-B2B1-9CF15BCEB83B}" type="presOf" srcId="{D546635F-000B-49DF-BB26-293CCA777400}" destId="{0E12AD21-08CC-4736-A269-DD5234F9D874}" srcOrd="1" destOrd="2" presId="urn:microsoft.com/office/officeart/2005/8/layout/vList4"/>
     <dgm:cxn modelId="{22A4C7D2-C14A-4622-8C4E-3FE51F50DCC3}" type="presOf" srcId="{02A34BC0-F8BA-4A89-87A4-4F20079DFD06}" destId="{CFFDF23F-D296-4CDF-8EE4-8A672559E207}" srcOrd="1" destOrd="0" presId="urn:microsoft.com/office/officeart/2005/8/layout/vList4"/>
-    <dgm:cxn modelId="{A70C9FD5-2935-4C81-937A-B6C05F5E54BA}" type="presOf" srcId="{2E221207-005F-49CB-81E1-6D036D64322B}" destId="{54FC4CB6-0791-48D3-B2C5-2E99B8AFCFF7}" srcOrd="0" destOrd="2" presId="urn:microsoft.com/office/officeart/2005/8/layout/vList4"/>
     <dgm:cxn modelId="{AC0A7FF3-EEC4-470A-823E-BF7AF1556A99}" srcId="{99FF0D0F-282A-4030-9AF5-3B7621881539}" destId="{D546635F-000B-49DF-BB26-293CCA777400}" srcOrd="1" destOrd="0" parTransId="{5437D343-BECF-4620-B6C7-7088D8BBD91B}" sibTransId="{B01A0825-9EDF-4B9A-B345-1B486D914AD4}"/>
     <dgm:cxn modelId="{7ABE08FD-4ED4-44FB-BFBA-794B6C5FA813}" type="presOf" srcId="{EA3B2395-55AF-495E-9D6B-329D2886612F}" destId="{39AFE128-ACF6-44CA-B18B-64F5782CF210}" srcOrd="0" destOrd="1" presId="urn:microsoft.com/office/officeart/2005/8/layout/vList4"/>
     <dgm:cxn modelId="{DA463EE6-78DB-4E59-8099-EBA029F401B0}" type="presParOf" srcId="{6E1E561E-88C1-49C6-A3F7-DE4B9AD43273}" destId="{F70979D0-5925-4EC3-AD84-986E0EC7B0D8}" srcOrd="0" destOrd="0" presId="urn:microsoft.com/office/officeart/2005/8/layout/vList4"/>
@@ -1452,7 +1457,7 @@
           </a:pPr>
           <a:r>
             <a:rPr lang="es-MX" sz="2600" kern="1200" dirty="0"/>
-            <a:t>Nombre de estudiante</a:t>
+            <a:t>Benjamín Alejandro Bravo Rivadeneira</a:t>
           </a:r>
           <a:endParaRPr lang="es-CL" sz="2600" kern="1200" dirty="0"/>
         </a:p>
@@ -1471,7 +1476,7 @@
           </a:pPr>
           <a:r>
             <a:rPr lang="es-MX" sz="2000" kern="1200" dirty="0"/>
-            <a:t>Cargo</a:t>
+            <a:t>Gestor de proyectos y Líder del proyecto</a:t>
           </a:r>
           <a:endParaRPr lang="es-CL" sz="2000" kern="1200" dirty="0"/>
         </a:p>
@@ -1490,7 +1495,7 @@
           </a:pPr>
           <a:r>
             <a:rPr lang="es-MX" sz="2000" kern="1200" dirty="0"/>
-            <a:t>Funciones desempeñadas</a:t>
+            <a:t>Tener los documentos, ayudar y guiar al equipo</a:t>
           </a:r>
           <a:endParaRPr lang="es-CL" sz="2000" kern="1200" dirty="0"/>
         </a:p>
@@ -1515,15 +1520,19 @@
             <a:gd name="adj" fmla="val 10000"/>
           </a:avLst>
         </a:prstGeom>
-        <a:solidFill>
-          <a:schemeClr val="accent5">
-            <a:tint val="50000"/>
-            <a:hueOff val="0"/>
-            <a:satOff val="0"/>
-            <a:lumOff val="0"/>
-            <a:alphaOff val="0"/>
-          </a:schemeClr>
-        </a:solidFill>
+        <a:blipFill>
+          <a:blip xmlns:r="http://schemas.openxmlformats.org/officeDocument/2006/relationships" r:embed="rId1">
+            <a:extLst>
+              <a:ext uri="{28A0092B-C50C-407E-A947-70E740481C1C}">
+                <a14:useLocalDpi xmlns:a14="http://schemas.microsoft.com/office/drawing/2010/main" val="0"/>
+              </a:ext>
+            </a:extLst>
+          </a:blip>
+          <a:srcRect/>
+          <a:stretch>
+            <a:fillRect t="-66000" b="-66000"/>
+          </a:stretch>
+        </a:blipFill>
         <a:ln>
           <a:noFill/>
         </a:ln>
@@ -3330,7 +3339,7 @@
           <a:p>
             <a:fld id="{6E1704C8-43E3-4F4F-BE90-356A640D5754}" type="datetimeFigureOut">
               <a:rPr lang="es-CL" smtClean="0"/>
-              <a:t>28-10-2023</a:t>
+              <a:t>17-11-2025</a:t>
             </a:fld>
             <a:endParaRPr lang="es-CL"/>
           </a:p>
@@ -3533,7 +3542,7 @@
           <a:p>
             <a:fld id="{6E1704C8-43E3-4F4F-BE90-356A640D5754}" type="datetimeFigureOut">
               <a:rPr lang="es-CL" smtClean="0"/>
-              <a:t>28-10-2023</a:t>
+              <a:t>17-11-2025</a:t>
             </a:fld>
             <a:endParaRPr lang="es-CL"/>
           </a:p>
@@ -3746,7 +3755,7 @@
           <a:p>
             <a:fld id="{6E1704C8-43E3-4F4F-BE90-356A640D5754}" type="datetimeFigureOut">
               <a:rPr lang="es-CL" smtClean="0"/>
-              <a:t>28-10-2023</a:t>
+              <a:t>17-11-2025</a:t>
             </a:fld>
             <a:endParaRPr lang="es-CL"/>
           </a:p>
@@ -3949,7 +3958,7 @@
           <a:p>
             <a:fld id="{6E1704C8-43E3-4F4F-BE90-356A640D5754}" type="datetimeFigureOut">
               <a:rPr lang="es-CL" smtClean="0"/>
-              <a:t>28-10-2023</a:t>
+              <a:t>17-11-2025</a:t>
             </a:fld>
             <a:endParaRPr lang="es-CL"/>
           </a:p>
@@ -4228,7 +4237,7 @@
           <a:p>
             <a:fld id="{6E1704C8-43E3-4F4F-BE90-356A640D5754}" type="datetimeFigureOut">
               <a:rPr lang="es-CL" smtClean="0"/>
-              <a:t>28-10-2023</a:t>
+              <a:t>17-11-2025</a:t>
             </a:fld>
             <a:endParaRPr lang="es-CL"/>
           </a:p>
@@ -4499,7 +4508,7 @@
           <a:p>
             <a:fld id="{6E1704C8-43E3-4F4F-BE90-356A640D5754}" type="datetimeFigureOut">
               <a:rPr lang="es-CL" smtClean="0"/>
-              <a:t>28-10-2023</a:t>
+              <a:t>17-11-2025</a:t>
             </a:fld>
             <a:endParaRPr lang="es-CL"/>
           </a:p>
@@ -4917,7 +4926,7 @@
           <a:p>
             <a:fld id="{6E1704C8-43E3-4F4F-BE90-356A640D5754}" type="datetimeFigureOut">
               <a:rPr lang="es-CL" smtClean="0"/>
-              <a:t>28-10-2023</a:t>
+              <a:t>17-11-2025</a:t>
             </a:fld>
             <a:endParaRPr lang="es-CL"/>
           </a:p>
@@ -5062,7 +5071,7 @@
           <a:p>
             <a:fld id="{6E1704C8-43E3-4F4F-BE90-356A640D5754}" type="datetimeFigureOut">
               <a:rPr lang="es-CL" smtClean="0"/>
-              <a:t>28-10-2023</a:t>
+              <a:t>17-11-2025</a:t>
             </a:fld>
             <a:endParaRPr lang="es-CL"/>
           </a:p>
@@ -5178,7 +5187,7 @@
           <a:p>
             <a:fld id="{6E1704C8-43E3-4F4F-BE90-356A640D5754}" type="datetimeFigureOut">
               <a:rPr lang="es-CL" smtClean="0"/>
-              <a:t>28-10-2023</a:t>
+              <a:t>17-11-2025</a:t>
             </a:fld>
             <a:endParaRPr lang="es-CL"/>
           </a:p>
@@ -5494,7 +5503,7 @@
           <a:p>
             <a:fld id="{6E1704C8-43E3-4F4F-BE90-356A640D5754}" type="datetimeFigureOut">
               <a:rPr lang="es-CL" smtClean="0"/>
-              <a:t>28-10-2023</a:t>
+              <a:t>17-11-2025</a:t>
             </a:fld>
             <a:endParaRPr lang="es-CL"/>
           </a:p>
@@ -5786,7 +5795,7 @@
           <a:p>
             <a:fld id="{6E1704C8-43E3-4F4F-BE90-356A640D5754}" type="datetimeFigureOut">
               <a:rPr lang="es-CL" smtClean="0"/>
-              <a:t>28-10-2023</a:t>
+              <a:t>17-11-2025</a:t>
             </a:fld>
             <a:endParaRPr lang="es-CL"/>
           </a:p>
@@ -6032,7 +6041,7 @@
           <a:p>
             <a:fld id="{6E1704C8-43E3-4F4F-BE90-356A640D5754}" type="datetimeFigureOut">
               <a:rPr lang="es-CL" smtClean="0"/>
-              <a:t>28-10-2023</a:t>
+              <a:t>17-11-2025</a:t>
             </a:fld>
             <a:endParaRPr lang="es-CL"/>
           </a:p>
@@ -6514,7 +6523,7 @@
         <p:spPr>
           <a:xfrm>
             <a:off x="1" y="2707792"/>
-            <a:ext cx="12191999" cy="1138773"/>
+            <a:ext cx="12191999" cy="1815882"/>
           </a:xfrm>
           <a:prstGeom prst="rect">
             <a:avLst/>
@@ -6530,7 +6539,44 @@
             <a:pPr algn="ctr"/>
             <a:r>
               <a:rPr lang="es-MX" sz="4400" dirty="0"/>
-              <a:t>PROYECTO “NOMBRE DEL PROYECTO”</a:t>
+              <a:t>PROYECTO “I</a:t>
+            </a:r>
+            <a:r>
+              <a:rPr lang="es-CL" sz="4400" b="1" i="0" dirty="0" err="1">
+                <a:effectLst/>
+              </a:rPr>
+              <a:t>nclushop</a:t>
+            </a:r>
+            <a:r>
+              <a:rPr lang="es-CL" sz="4400" b="1" i="0" dirty="0">
+                <a:effectLst/>
+              </a:rPr>
+              <a:t> : Herramientas para un </a:t>
+            </a:r>
+          </a:p>
+          <a:p>
+            <a:pPr algn="ctr"/>
+            <a:r>
+              <a:rPr lang="es-CL" sz="4400" b="1" i="0" dirty="0">
+                <a:effectLst/>
+              </a:rPr>
+              <a:t>E-</a:t>
+            </a:r>
+            <a:r>
+              <a:rPr lang="es-CL" sz="4400" b="1" i="0" dirty="0" err="1">
+                <a:effectLst/>
+              </a:rPr>
+              <a:t>commerce</a:t>
+            </a:r>
+            <a:r>
+              <a:rPr lang="es-CL" sz="4400" b="1" i="0" dirty="0">
+                <a:effectLst/>
+              </a:rPr>
+              <a:t> inclusivo</a:t>
+            </a:r>
+            <a:r>
+              <a:rPr lang="es-MX" sz="4400" dirty="0"/>
+              <a:t>”</a:t>
             </a:r>
           </a:p>
           <a:p>
@@ -7345,7 +7391,7 @@
           <p:nvPr>
             <p:extLst>
               <p:ext uri="{D42A27DB-BD31-4B8C-83A1-F6EECF244321}">
-                <p14:modId xmlns:p14="http://schemas.microsoft.com/office/powerpoint/2010/main" val="809683936"/>
+                <p14:modId xmlns:p14="http://schemas.microsoft.com/office/powerpoint/2010/main" val="972565903"/>
               </p:ext>
             </p:extLst>
           </p:nvPr>
@@ -7786,8 +7832,8 @@
           <a:p>
             <a:pPr algn="just"/>
             <a:r>
-              <a:rPr lang="es-MX" sz="1800" dirty="0"/>
-              <a:t>Descripción</a:t>
+              <a:rPr lang="es-MX" dirty="0"/>
+              <a:t>El proyecto busca desarrollar una plataforma de comercio electrónico inclusiva, que permita a personas con discapacidad visual o dificultades motrices navegar y comprar productos usando comandos de voz y narración automática. Además, contará con un asistente virtual para guiar el proceso de compra.</a:t>
             </a:r>
             <a:endParaRPr lang="es-CL" sz="1800" dirty="0"/>
           </a:p>
@@ -7852,7 +7898,7 @@
             <a:pPr lvl="0" algn="just"/>
             <a:r>
               <a:rPr lang="es-MX" dirty="0"/>
-              <a:t>Descripción</a:t>
+              <a:t>Nuestra propuesta de solución es un</a:t>
             </a:r>
             <a:endParaRPr lang="es-CL" sz="1800" dirty="0"/>
           </a:p>

</xml_diff>

<commit_message>
continuación de rellenado de documentos
se sigue rellenando ppt final
</commit_message>
<xml_diff>
--- a/Fase 3/Evidencias Grupales/Formato Presentación final.pptx
+++ b/Fase 3/Evidencias Grupales/Formato Presentación final.pptx
@@ -3339,7 +3339,7 @@
           <a:p>
             <a:fld id="{6E1704C8-43E3-4F4F-BE90-356A640D5754}" type="datetimeFigureOut">
               <a:rPr lang="es-CL" smtClean="0"/>
-              <a:t>17-11-2025</a:t>
+              <a:t>18-11-2025</a:t>
             </a:fld>
             <a:endParaRPr lang="es-CL"/>
           </a:p>
@@ -3542,7 +3542,7 @@
           <a:p>
             <a:fld id="{6E1704C8-43E3-4F4F-BE90-356A640D5754}" type="datetimeFigureOut">
               <a:rPr lang="es-CL" smtClean="0"/>
-              <a:t>17-11-2025</a:t>
+              <a:t>18-11-2025</a:t>
             </a:fld>
             <a:endParaRPr lang="es-CL"/>
           </a:p>
@@ -3755,7 +3755,7 @@
           <a:p>
             <a:fld id="{6E1704C8-43E3-4F4F-BE90-356A640D5754}" type="datetimeFigureOut">
               <a:rPr lang="es-CL" smtClean="0"/>
-              <a:t>17-11-2025</a:t>
+              <a:t>18-11-2025</a:t>
             </a:fld>
             <a:endParaRPr lang="es-CL"/>
           </a:p>
@@ -3958,7 +3958,7 @@
           <a:p>
             <a:fld id="{6E1704C8-43E3-4F4F-BE90-356A640D5754}" type="datetimeFigureOut">
               <a:rPr lang="es-CL" smtClean="0"/>
-              <a:t>17-11-2025</a:t>
+              <a:t>18-11-2025</a:t>
             </a:fld>
             <a:endParaRPr lang="es-CL"/>
           </a:p>
@@ -4237,7 +4237,7 @@
           <a:p>
             <a:fld id="{6E1704C8-43E3-4F4F-BE90-356A640D5754}" type="datetimeFigureOut">
               <a:rPr lang="es-CL" smtClean="0"/>
-              <a:t>17-11-2025</a:t>
+              <a:t>18-11-2025</a:t>
             </a:fld>
             <a:endParaRPr lang="es-CL"/>
           </a:p>
@@ -4508,7 +4508,7 @@
           <a:p>
             <a:fld id="{6E1704C8-43E3-4F4F-BE90-356A640D5754}" type="datetimeFigureOut">
               <a:rPr lang="es-CL" smtClean="0"/>
-              <a:t>17-11-2025</a:t>
+              <a:t>18-11-2025</a:t>
             </a:fld>
             <a:endParaRPr lang="es-CL"/>
           </a:p>
@@ -4926,7 +4926,7 @@
           <a:p>
             <a:fld id="{6E1704C8-43E3-4F4F-BE90-356A640D5754}" type="datetimeFigureOut">
               <a:rPr lang="es-CL" smtClean="0"/>
-              <a:t>17-11-2025</a:t>
+              <a:t>18-11-2025</a:t>
             </a:fld>
             <a:endParaRPr lang="es-CL"/>
           </a:p>
@@ -5071,7 +5071,7 @@
           <a:p>
             <a:fld id="{6E1704C8-43E3-4F4F-BE90-356A640D5754}" type="datetimeFigureOut">
               <a:rPr lang="es-CL" smtClean="0"/>
-              <a:t>17-11-2025</a:t>
+              <a:t>18-11-2025</a:t>
             </a:fld>
             <a:endParaRPr lang="es-CL"/>
           </a:p>
@@ -5187,7 +5187,7 @@
           <a:p>
             <a:fld id="{6E1704C8-43E3-4F4F-BE90-356A640D5754}" type="datetimeFigureOut">
               <a:rPr lang="es-CL" smtClean="0"/>
-              <a:t>17-11-2025</a:t>
+              <a:t>18-11-2025</a:t>
             </a:fld>
             <a:endParaRPr lang="es-CL"/>
           </a:p>
@@ -5503,7 +5503,7 @@
           <a:p>
             <a:fld id="{6E1704C8-43E3-4F4F-BE90-356A640D5754}" type="datetimeFigureOut">
               <a:rPr lang="es-CL" smtClean="0"/>
-              <a:t>17-11-2025</a:t>
+              <a:t>18-11-2025</a:t>
             </a:fld>
             <a:endParaRPr lang="es-CL"/>
           </a:p>
@@ -5795,7 +5795,7 @@
           <a:p>
             <a:fld id="{6E1704C8-43E3-4F4F-BE90-356A640D5754}" type="datetimeFigureOut">
               <a:rPr lang="es-CL" smtClean="0"/>
-              <a:t>17-11-2025</a:t>
+              <a:t>18-11-2025</a:t>
             </a:fld>
             <a:endParaRPr lang="es-CL"/>
           </a:p>
@@ -6041,7 +6041,7 @@
           <a:p>
             <a:fld id="{6E1704C8-43E3-4F4F-BE90-356A640D5754}" type="datetimeFigureOut">
               <a:rPr lang="es-CL" smtClean="0"/>
-              <a:t>17-11-2025</a:t>
+              <a:t>18-11-2025</a:t>
             </a:fld>
             <a:endParaRPr lang="es-CL"/>
           </a:p>
@@ -7442,7 +7442,45 @@
                   </a:schemeClr>
                 </a:solidFill>
               </a:rPr>
-              <a:t>PROYECTO “NOMBRE DEL PROYECTO”</a:t>
+              <a:t>PROYECTO  “</a:t>
+            </a:r>
+            <a:r>
+              <a:rPr lang="es-MX" sz="1800" dirty="0"/>
+              <a:t>I</a:t>
+            </a:r>
+            <a:r>
+              <a:rPr lang="es-CL" sz="1800" i="0" dirty="0" err="1">
+                <a:effectLst/>
+              </a:rPr>
+              <a:t>nclushop</a:t>
+            </a:r>
+            <a:r>
+              <a:rPr lang="es-CL" sz="1800" i="0" dirty="0">
+                <a:effectLst/>
+              </a:rPr>
+              <a:t> : Herramientas para un E-</a:t>
+            </a:r>
+            <a:r>
+              <a:rPr lang="es-CL" sz="1800" i="0" dirty="0" err="1">
+                <a:effectLst/>
+              </a:rPr>
+              <a:t>commerce</a:t>
+            </a:r>
+            <a:r>
+              <a:rPr lang="es-CL" sz="1800" i="0" dirty="0">
+                <a:effectLst/>
+              </a:rPr>
+              <a:t> inclusivo</a:t>
+            </a:r>
+            <a:r>
+              <a:rPr lang="es-MX" dirty="0">
+                <a:solidFill>
+                  <a:schemeClr val="bg2">
+                    <a:lumMod val="50000"/>
+                  </a:schemeClr>
+                </a:solidFill>
+              </a:rPr>
+              <a:t>”</a:t>
             </a:r>
           </a:p>
         </p:txBody>
@@ -7898,7 +7936,15 @@
             <a:pPr lvl="0" algn="just"/>
             <a:r>
               <a:rPr lang="es-MX" dirty="0"/>
-              <a:t>Nuestra propuesta de solución es un</a:t>
+              <a:t>Nuestra propuesta de solución es un kit de herramientas (Plug-In) para que personas con las discapacidades anteriormente mencionadas, mediante los comandos de Voz  y la narrativa automática en </a:t>
+            </a:r>
+            <a:r>
+              <a:rPr lang="es-MX" dirty="0" err="1"/>
+              <a:t>conjuto</a:t>
+            </a:r>
+            <a:r>
+              <a:rPr lang="es-MX" dirty="0"/>
+              <a:t> </a:t>
             </a:r>
             <a:endParaRPr lang="es-CL" sz="1800" dirty="0"/>
           </a:p>
@@ -8242,7 +8288,45 @@
                   </a:schemeClr>
                 </a:solidFill>
               </a:rPr>
-              <a:t>PROYECTO “NOMBRE DEL PROYECTO”</a:t>
+              <a:t>PROYECTO  “</a:t>
+            </a:r>
+            <a:r>
+              <a:rPr lang="es-MX" sz="1800" dirty="0"/>
+              <a:t>I</a:t>
+            </a:r>
+            <a:r>
+              <a:rPr lang="es-CL" sz="1800" i="0" dirty="0" err="1">
+                <a:effectLst/>
+              </a:rPr>
+              <a:t>nclushop</a:t>
+            </a:r>
+            <a:r>
+              <a:rPr lang="es-CL" sz="1800" i="0" dirty="0">
+                <a:effectLst/>
+              </a:rPr>
+              <a:t> : Herramientas para un E-</a:t>
+            </a:r>
+            <a:r>
+              <a:rPr lang="es-CL" sz="1800" i="0" dirty="0" err="1">
+                <a:effectLst/>
+              </a:rPr>
+              <a:t>commerce</a:t>
+            </a:r>
+            <a:r>
+              <a:rPr lang="es-CL" sz="1800" i="0" dirty="0">
+                <a:effectLst/>
+              </a:rPr>
+              <a:t> inclusivo</a:t>
+            </a:r>
+            <a:r>
+              <a:rPr lang="es-MX" dirty="0">
+                <a:solidFill>
+                  <a:schemeClr val="bg2">
+                    <a:lumMod val="50000"/>
+                  </a:schemeClr>
+                </a:solidFill>
+              </a:rPr>
+              <a:t>”</a:t>
             </a:r>
           </a:p>
         </p:txBody>
@@ -8429,10 +8513,6 @@
           <a:lstStyle/>
           <a:p>
             <a:pPr algn="ctr"/>
-            <a:r>
-              <a:rPr lang="es-MX" dirty="0"/>
-              <a:t>Descripción</a:t>
-            </a:r>
             <a:endParaRPr lang="es-CL" dirty="0"/>
           </a:p>
         </p:txBody>

</xml_diff>